<commit_message>
Checkpoint current slide edits before F03 rewrite
Co-authored-by: Copilot <223556219+Copilot@users.noreply.github.com>
</commit_message>
<xml_diff>
--- a/docs/slides/pptx/M2-finding.pptx
+++ b/docs/slides/pptx/M2-finding.pptx
@@ -172,7 +172,7 @@
   <pc:docChgLst>
     <pc:chgData name="J. Tower" userId="9d06de10716639e5" providerId="LiveId" clId="{F8931099-75CA-5660-A155-55881DF68D84}"/>
     <pc:docChg chg="undo redo custSel addSld delSld modSld sldOrd modSection">
-      <pc:chgData name="J. Tower" userId="9d06de10716639e5" providerId="LiveId" clId="{F8931099-75CA-5660-A155-55881DF68D84}" dt="2026-09-16T13:41:30.984" v="1229" actId="20577"/>
+      <pc:chgData name="J. Tower" userId="9d06de10716639e5" providerId="LiveId" clId="{F8931099-75CA-5660-A155-55881DF68D84}" dt="2026-09-16T14:37:33.956" v="1235" actId="20577"/>
       <pc:docMkLst>
         <pc:docMk/>
       </pc:docMkLst>
@@ -452,6 +452,36 @@
           </ac:spMkLst>
         </pc:spChg>
       </pc:sldChg>
+      <pc:sldChg chg="modSp mod">
+        <pc:chgData name="J. Tower" userId="9d06de10716639e5" providerId="LiveId" clId="{F8931099-75CA-5660-A155-55881DF68D84}" dt="2026-09-16T14:37:06.010" v="1234" actId="20577"/>
+        <pc:sldMkLst>
+          <pc:docMk/>
+          <pc:sldMk cId="0" sldId="616"/>
+        </pc:sldMkLst>
+        <pc:spChg chg="mod">
+          <ac:chgData name="J. Tower" userId="9d06de10716639e5" providerId="LiveId" clId="{F8931099-75CA-5660-A155-55881DF68D84}" dt="2026-09-16T14:37:06.010" v="1234" actId="20577"/>
+          <ac:spMkLst>
+            <pc:docMk/>
+            <pc:sldMk cId="0" sldId="616"/>
+            <ac:spMk id="3" creationId="{00000000-0000-0000-0000-000000000000}"/>
+          </ac:spMkLst>
+        </pc:spChg>
+      </pc:sldChg>
+      <pc:sldChg chg="modSp mod">
+        <pc:chgData name="J. Tower" userId="9d06de10716639e5" providerId="LiveId" clId="{F8931099-75CA-5660-A155-55881DF68D84}" dt="2026-09-16T14:37:33.956" v="1235" actId="20577"/>
+        <pc:sldMkLst>
+          <pc:docMk/>
+          <pc:sldMk cId="0" sldId="618"/>
+        </pc:sldMkLst>
+        <pc:spChg chg="mod">
+          <ac:chgData name="J. Tower" userId="9d06de10716639e5" providerId="LiveId" clId="{F8931099-75CA-5660-A155-55881DF68D84}" dt="2026-09-16T14:37:33.956" v="1235" actId="20577"/>
+          <ac:spMkLst>
+            <pc:docMk/>
+            <pc:sldMk cId="0" sldId="618"/>
+            <ac:spMk id="3" creationId="{00000000-0000-0000-0000-000000000000}"/>
+          </ac:spMkLst>
+        </pc:spChg>
+      </pc:sldChg>
     </pc:docChg>
   </pc:docChgLst>
 </pc:chgInfo>
@@ -2730,10 +2760,11 @@
           <a:lstStyle/>
           <a:p>
             <a:r>
+              <a:rPr dirty="0"/>
               <a:t>~6 min · </a:t>
             </a:r>
             <a:r>
-              <a:rPr>
+              <a:rPr dirty="0">
                 <a:latin typeface="Consolas"/>
               </a:rPr>
               <a:t>cd modules/M2-finding/F06-recommendations/dotnet</a:t>
@@ -2741,113 +2772,151 @@
           </a:p>
           <a:p>
             <a:r>
+              <a:rPr dirty="0"/>
               <a:t>Files: </a:t>
             </a:r>
             <a:r>
-              <a:rPr>
+              <a:rPr dirty="0" err="1">
                 <a:latin typeface="Consolas"/>
               </a:rPr>
               <a:t>trails.json</a:t>
             </a:r>
             <a:r>
+              <a:rPr dirty="0"/>
               <a:t> = 30 trails · </a:t>
             </a:r>
             <a:r>
-              <a:rPr>
+              <a:rPr dirty="0">
                 <a:latin typeface="Consolas"/>
               </a:rPr>
-              <a:t>trail-embeddings.json</a:t>
-            </a:r>
-            <a:r>
-              <a:t> = precomputed vectors for this 30-trail slice (not 04's full set) · </a:t>
-            </a:r>
-            <a:r>
-              <a:rPr>
+              <a:t>trail-</a:t>
+            </a:r>
+            <a:r>
+              <a:rPr dirty="0" err="1">
                 <a:latin typeface="Consolas"/>
               </a:rPr>
-              <a:t>gear-reviews.jsonl</a:t>
-            </a:r>
-            <a:r>
+              <a:t>embeddings.json</a:t>
+            </a:r>
+            <a:r>
+              <a:rPr dirty="0"/>
+              <a:t> = 04's vectors, precomputed · </a:t>
+            </a:r>
+            <a:r>
+              <a:rPr dirty="0">
+                <a:latin typeface="Consolas"/>
+              </a:rPr>
+              <a:t>gear-</a:t>
+            </a:r>
+            <a:r>
+              <a:rPr dirty="0" err="1">
+                <a:latin typeface="Consolas"/>
+              </a:rPr>
+              <a:t>reviews.jsonl</a:t>
+            </a:r>
+            <a:r>
+              <a:rPr dirty="0"/>
               <a:t> = 300 reviews</a:t>
             </a:r>
           </a:p>
           <a:p>
             <a:r>
-              <a:t>Args: a trail id or name (default trail-0117, Avalanche Lake) · </a:t>
-            </a:r>
-            <a:r>
-              <a:rPr>
+              <a:rPr dirty="0" err="1"/>
+              <a:t>Args</a:t>
+            </a:r>
+            <a:r>
+              <a:rPr dirty="0"/>
+              <a:t>: a trail id or name (default trail-0117, Avalanche Lake) · </a:t>
+            </a:r>
+            <a:r>
+              <a:rPr dirty="0">
                 <a:latin typeface="Consolas"/>
               </a:rPr>
               <a:t>--gear &lt;product&gt;</a:t>
             </a:r>
             <a:r>
+              <a:rPr dirty="0"/>
               <a:t> = same trick over review text</a:t>
             </a:r>
           </a:p>
           <a:p>
             <a:r>
+              <a:rPr dirty="0"/>
               <a:t>1. Avalanche Lake Trail page. What belongs at the bottom of this screen?</a:t>
             </a:r>
           </a:p>
           <a:p>
             <a:r>
+              <a:rPr dirty="0"/>
               <a:t>2. Before: </a:t>
             </a:r>
             <a:r>
-              <a:rPr>
+              <a:rPr dirty="0">
                 <a:latin typeface="Consolas"/>
               </a:rPr>
               <a:t>cd starter &amp;&amp; dotnet run</a:t>
             </a:r>
             <a:r>
+              <a:rPr dirty="0"/>
               <a:t>. Random picks. That is what most apps ship.</a:t>
             </a:r>
           </a:p>
           <a:p>
             <a:r>
+              <a:rPr dirty="0"/>
               <a:t>3. After: </a:t>
             </a:r>
             <a:r>
-              <a:rPr>
+              <a:rPr dirty="0">
                 <a:latin typeface="Consolas"/>
               </a:rPr>
               <a:t>cd ../complete &amp;&amp; dotnet run</a:t>
             </a:r>
             <a:r>
+              <a:rPr dirty="0"/>
               <a:t>. Same vectors as 04, nothing new embedded. Lakes cluster, but mostly hard, and one has no lake.</a:t>
             </a:r>
           </a:p>
           <a:p>
             <a:r>
+              <a:rPr dirty="0"/>
               <a:t>4. Difficulty and park are in the catalog, not the text. Similarity gets candidates; metadata re-ranks.</a:t>
             </a:r>
           </a:p>
           <a:p>
             <a:r>
+              <a:rPr dirty="0"/>
               <a:t>5. </a:t>
             </a:r>
             <a:r>
-              <a:rPr>
+              <a:rPr dirty="0">
                 <a:latin typeface="Consolas"/>
               </a:rPr>
               <a:t>dotnet run -- --gear Cascade 65</a:t>
             </a:r>
             <a:r>
+              <a:rPr dirty="0"/>
               <a:t>: the Cascade 40. Substitutes, not complements. What people use with it lives in the reviews: the bear canister, in </a:t>
             </a:r>
             <a:r>
-              <a:rPr>
+              <a:rPr dirty="0">
                 <a:latin typeface="Consolas"/>
               </a:rPr>
-              <a:t>expected-output.md</a:t>
-            </a:r>
-            <a:r>
+              <a:t>expected-</a:t>
+            </a:r>
+            <a:r>
+              <a:rPr dirty="0" err="1">
+                <a:latin typeface="Consolas"/>
+              </a:rPr>
+              <a:t>output.md</a:t>
+            </a:r>
+            <a:r>
+              <a:rPr dirty="0"/>
               <a:t>.</a:t>
             </a:r>
           </a:p>
           <a:p>
             <a:r>
+              <a:rPr dirty="0"/>
               <a:t>Cut: 5.</a:t>
             </a:r>
           </a:p>
@@ -16222,11 +16291,11 @@
               </a:spcAft>
             </a:pPr>
             <a:r>
-              <a:rPr sz="2800" b="1"/>
+              <a:rPr sz="2800" b="1" dirty="0"/>
               <a:t>When:</a:t>
             </a:r>
             <a:r>
-              <a:rPr sz="2800"/>
+              <a:rPr sz="2800" dirty="0"/>
               <a:t> Users finish one thing and the product offers no next step.</a:t>
             </a:r>
           </a:p>
@@ -16237,12 +16306,20 @@
               </a:spcAft>
             </a:pPr>
             <a:r>
-              <a:rPr sz="2800" b="1"/>
+              <a:rPr sz="2800" b="1" dirty="0"/>
               <a:t>Think:</a:t>
             </a:r>
             <a:r>
-              <a:rPr sz="2800"/>
-              <a:t> "The same vectors that power our search give us 'more like this' for free."</a:t>
+              <a:rPr sz="2800" dirty="0"/>
+              <a:t> "The same vectors that power our search give </a:t>
+            </a:r>
+            <a:r>
+              <a:rPr lang="en-US" sz="2800" dirty="0"/>
+              <a:t>us</a:t>
+            </a:r>
+            <a:r>
+              <a:rPr sz="2800" dirty="0"/>
+              <a:t> 'more like this' for free."</a:t>
             </a:r>
           </a:p>
           <a:p>
@@ -16251,7 +16328,7 @@
                 <a:spcPts val="1400"/>
               </a:spcAft>
             </a:pPr>
-            <a:endParaRPr sz="2800"/>
+            <a:endParaRPr sz="2800" dirty="0"/>
           </a:p>
           <a:p>
             <a:pPr>
@@ -16260,11 +16337,11 @@
               </a:spcAft>
             </a:pPr>
             <a:r>
-              <a:rPr sz="2800" b="1"/>
+              <a:rPr sz="2800" b="1" dirty="0"/>
               <a:t>Difficulty:</a:t>
             </a:r>
             <a:r>
-              <a:rPr sz="2800"/>
+              <a:rPr sz="2800" dirty="0"/>
               <a:t> </a:t>
             </a:r>
           </a:p>
@@ -16662,12 +16739,12 @@
           <a:bodyPr wrap="square"/>
           <a:lstStyle/>
           <a:p>
-            <a:endParaRPr/>
-          </a:p>
-          <a:p>
-            <a:r>
-              <a:rPr sz="2800"/>
-              <a:t>How'd it go?				  Observations?			        Questions?</a:t>
+            <a:endParaRPr dirty="0"/>
+          </a:p>
+          <a:p>
+            <a:r>
+              <a:rPr sz="2800" dirty="0"/>
+              <a:t>How'd it go?			  Observations?			        Questions?</a:t>
             </a:r>
           </a:p>
         </p:txBody>

</xml_diff>